<commit_message>
Mobility OS Maroc : livre l'Etape 5 (materiel jour J pour la presentation)
Ajoute les notes de presentateur (parle, diapo par diapo) dans
presentation-partenaire.pptx, et 05-jour-j.md : checklist avant depart,
deroule minute (~25-30 min), FAQ des objections probables, actions de
cloture. Ce chantier en 5 etapes est desormais complet ; la suite
depend de l'issue reelle de la presentation de samedi.

Co-Authored-By: Claude Sonnet 5 <noreply@anthropic.com>
Claude-Session: https://claude.ai/code/session_01W41D6M9CHKKNRgF873mhme
</commit_message>
<xml_diff>
--- a/mobility-os-maroc/04-dossier-commercial/presentation-partenaire.pptx
+++ b/mobility-os-maroc/04-dossier-commercial/presentation-partenaire.pptx
@@ -739,7 +739,7 @@
           <a:p>
             <a:r>
               <a:rPr lang="en-US" dirty="0"/>
-              <a:t/>
+              <a:t>Merci de nous recevoir. En une vingtaine de minutes, je vais vous montrer un produit qui existe déjà — pas juste une idée sur slide — et vous expliquer pourquoi on pense que vous êtes le bon premier partenaire pour le lancer.</a:t>
             </a:r>
             <a:endParaRPr lang="en-US" dirty="0"/>
           </a:p>
@@ -827,7 +827,7 @@
           <a:p>
             <a:r>
               <a:rPr lang="en-US" dirty="0"/>
-              <a:t/>
+              <a:t>Ce qu'on vous demande est volontairement limité au démarrage : quelques chauffeurs, un référent, vos tarifs. En échange, vous obtenez une plateforme complète, configurée à votre marque, avec support et bilan chiffré inclus. C'est une expression d'intérêt, pas un contrat définitif — on peut la signer aujourd'hui pour lancer le cadrage.</a:t>
             </a:r>
             <a:endParaRPr lang="en-US" dirty="0"/>
           </a:p>
@@ -915,7 +915,7 @@
           <a:p>
             <a:r>
               <a:rPr lang="en-US" dirty="0"/>
-              <a:t/>
+              <a:t>Si ça vous parle, voici les trois choses qu'il faudrait faire cette semaine pour démarrer. On peut signer l'expression d'intérêt aujourd'hui si vous êtes partant, ou fixer une date cette semaine pour le faire avec les bonnes personnes de votre côté. Merci pour votre temps.</a:t>
             </a:r>
             <a:endParaRPr lang="en-US" dirty="0"/>
           </a:p>
@@ -1003,7 +1003,7 @@
           <a:p>
             <a:r>
               <a:rPr lang="en-US" dirty="0"/>
-              <a:t/>
+              <a:t>Aujourd'hui, un opérateur de transport marocain gère ses courses par téléphone, sans app pour ses clients ni ses chauffeurs. Et quand il passe par une plateforme internationale, il ne la contrôle pas et ne touche aucun partage de revenu. Développer sa propre app, seul, est hors de portée.</a:t>
             </a:r>
             <a:endParaRPr lang="en-US" dirty="0"/>
           </a:p>
@@ -1091,7 +1091,7 @@
           <a:p>
             <a:r>
               <a:rPr lang="en-US" dirty="0"/>
-              <a:t/>
+              <a:t>Notre réponse : une seule plateforme technique, que chaque opérateur utilise sous sa propre marque. Vous ne devenez pas un sous-traitant d'une marque étrangère — vous restez vous-même aux yeux de vos clients et de vos chauffeurs. Et ça n'a rien d'un slide : je vais vous le montrer tout de suite.</a:t>
             </a:r>
             <a:endParaRPr lang="en-US" dirty="0"/>
           </a:p>
@@ -1179,7 +1179,7 @@
           <a:p>
             <a:r>
               <a:rPr lang="en-US" dirty="0"/>
-              <a:t/>
+              <a:t>Ce que vous voyez là tourne déjà — pas des maquettes graphiques, du code qui clique. C'est le moment de basculer sur les vraies apps ouvertes dans le navigateur (passager.html, chauffeur.html, dashboard.html) et de dérouler le parcours en direct : commander une course, l'accepter côté chauffeur, la terminer, la retrouver dans le dashboard. Cette diapo sert de filet de sécurité si la démo live pose un problème technique.</a:t>
             </a:r>
             <a:endParaRPr lang="en-US" dirty="0"/>
           </a:p>
@@ -1267,7 +1267,7 @@
           <a:p>
             <a:r>
               <a:rPr lang="en-US" dirty="0"/>
-              <a:t/>
+              <a:t>Et voici le point le plus important : ce que vous venez de voir peut porter votre marque, vos couleurs, votre logo — en quelques clics depuis votre dashboard, sans qu'on retouche une ligne de code. Si possible, montrer le changement en direct dans l'onglet Marque du dashboard plutôt que juste cette diapo.</a:t>
             </a:r>
             <a:endParaRPr lang="en-US" dirty="0"/>
           </a:p>
@@ -1355,7 +1355,7 @@
           <a:p>
             <a:r>
               <a:rPr lang="en-US" dirty="0"/>
-              <a:t/>
+              <a:t>Concrètement, voici comment on travaillerait ensemble : un coût de mise en service pour configurer votre marque et former vos équipes, un abonnement mensuel prévisible, et une commission qui nous aligne sur votre succès — on gagne quand vous gagnez.</a:t>
             </a:r>
             <a:endParaRPr lang="en-US" dirty="0"/>
           </a:p>
@@ -1443,7 +1443,7 @@
           <a:p>
             <a:r>
               <a:rPr lang="en-US" dirty="0"/>
-              <a:t/>
+              <a:t>Pour donner un ordre de grandeur, avec des volumes de démarrage réalistes : sur 3 mois de pilote, voici ce que ça représenterait. J'insiste — ce sont des hypothèses de travail pour cadrer la discussion, pas une facture. On les ajuste ensemble selon ce que vous connaissez du marché.</a:t>
             </a:r>
             <a:endParaRPr lang="en-US" dirty="0"/>
           </a:p>
@@ -1531,7 +1531,7 @@
           <a:p>
             <a:r>
               <a:rPr lang="en-US" dirty="0"/>
-              <a:t/>
+              <a:t>Ce qui rend ce modèle intéressant à long terme, pas seulement pour ce pilote : une seule plateforme derrière plusieurs marques, un onboarding qui reste une simple configuration, et une isolation stricte — vos chauffeurs et vos courses ne sont jamais mélangés avec ceux d'un autre opérateur, même dans la même ville.</a:t>
             </a:r>
             <a:endParaRPr lang="en-US" dirty="0"/>
           </a:p>
@@ -1619,7 +1619,7 @@
           <a:p>
             <a:r>
               <a:rPr lang="en-US" dirty="0"/>
-              <a:t/>
+              <a:t>Voici comment on démarrerait concrètement, étape par étape, sans vous demander un engagement disproportionné dès le premier jour : on cadre à petite échelle, on construit, on teste en cercle fermé avant d'ouvrir au public, et on fait un vrai bilan chiffré avant de parler d'aller plus loin.</a:t>
             </a:r>
             <a:endParaRPr lang="en-US" dirty="0"/>
           </a:p>

</xml_diff>